<commit_message>
Update pitch deck slides and PDF with automatic port fallback and updated quickstart info
</commit_message>
<xml_diff>
--- a/Desktop_Gremlin_Pitch_Deck.pptx
+++ b/Desktop_Gremlin_Pitch_Deck.pptx
@@ -4702,7 +4702,7 @@
                   <a:srgbClr val="F9FAFB"/>
                 </a:solidFill>
               </a:rPr>
-              <a:t>• In-Memory Room Store (Zero DB overhead)
+              <a:t>• Auto Port Fallback (EADDRINUSE auto-recovery)
 </a:t>
             </a:r>
             <a:pPr indent="0" marL="0">
@@ -4717,7 +4717,7 @@
                   <a:srgbClr val="F9FAFB"/>
                 </a:solidFill>
               </a:rPr>
-              <a:t>• CORS enabled for cross-origin tunneling
+              <a:t>• In-Memory Room Store (Zero DB overhead)
 </a:t>
             </a:r>
             <a:endParaRPr lang="en-US" sz="1300" dirty="0"/>
@@ -4848,7 +4848,7 @@
                   <a:srgbClr val="F9FAFB"/>
                 </a:solidFill>
               </a:rPr>
-              <a:t>• Fallback Simulation Mode: Mouse &amp; Keys work if camera is denied or unavailable
+              <a:t>• Fallback Simulation Mode: Mouse &amp; Keys work if camera is denied
 </a:t>
             </a:r>
             <a:pPr indent="0" marL="0">
@@ -5407,6 +5407,21 @@
                   <a:srgbClr val="D1FAE5"/>
                 </a:solidFill>
               </a:rPr>
+              <a:t>✅ Auto port collision fallback (3000 -&gt; 3001+)
+</a:t>
+            </a:r>
+            <a:pPr indent="0" marL="0">
+              <a:lnSpc>
+                <a:spcPts val="1600"/>
+              </a:lnSpc>
+              <a:buNone/>
+            </a:pPr>
+            <a:r>
+              <a:rPr lang="en-US" sz="1200" dirty="0">
+                <a:solidFill>
+                  <a:srgbClr val="D1FAE5"/>
+                </a:solidFill>
+              </a:rPr>
               <a:t>✅ Live Visitor 3D Avatar mirror preview
 </a:t>
             </a:r>
@@ -6401,7 +6416,7 @@
                   <a:srgbClr val="F9FAFB"/>
                 </a:solidFill>
               </a:rPr>
-              <a:t>npm start  ➔  Open http://localhost:3000 in two windows
+              <a:t>npm start  ➔  Auto-selects open port (3000, 3001, etc.)
 </a:t>
             </a:r>
             <a:pPr indent="0" marL="0">
@@ -6430,7 +6445,7 @@
                   <a:srgbClr val="F9FAFB"/>
                 </a:solidFill>
               </a:rPr>
-              <a:t>Click 'Host a Session' and share the 6-digit room code
+              <a:t>Open displayed terminal URL, click 'Host a Session'
 </a:t>
             </a:r>
             <a:pPr indent="0" marL="0">

</xml_diff>

<commit_message>
Implement full interactive remote desktop invasion, chaos suite, WebRTC screen streaming, and updated pitch deck presentation
</commit_message>
<xml_diff>
--- a/Desktop_Gremlin_Pitch_Deck.pptx
+++ b/Desktop_Gremlin_Pitch_Deck.pptx
@@ -2908,7 +2908,7 @@
                   <a:srgbClr val="9CA3AF"/>
                 </a:solidFill>
               </a:rPr>
-              <a:t>Shares room code &amp; displays simulated desktop canvas. Watches in real time as their friend's face-controlled avatar invades their workspace.</a:t>
+              <a:t>Hosts a retro simulated sandbox OS or streams their actual real Windows/Mac desktop via WebRTC getDisplayMedia, watching their friend's gremlin crawl over real open apps!</a:t>
             </a:r>
             <a:endParaRPr lang="en-US" sz="1200" dirty="0"/>
           </a:p>
@@ -2969,7 +2969,7 @@
                   <a:srgbClr val="10B981"/>
                 </a:solidFill>
               </a:rPr>
-              <a:t>🕹️ THE VISITOR (GREMLIN)</a:t>
+              <a:t>🕹️ THE VISITOR (DESKTOP INVADER)</a:t>
             </a:r>
             <a:endParaRPr lang="en-US" sz="1400" dirty="0"/>
           </a:p>
@@ -3008,7 +3008,7 @@
                   <a:srgbClr val="9CA3AF"/>
                 </a:solidFill>
               </a:rPr>
-              <a:t>Joins via code. Pilots the gremlin using webcam face tracking + WASD keyboard controls. Sees live mirror feedback and a remote desktop radar view.</a:t>
+              <a:t>Joins via code. Enters the other user's desktop directly! Drags and tosses files, smashes windows shut, sprays graffiti paw prints, and triggers earthquakes with live synchronized chaos.</a:t>
             </a:r>
             <a:endParaRPr lang="en-US" sz="1200" dirty="0"/>
           </a:p>
@@ -5484,7 +5484,7 @@
             <a:avLst/>
           </a:prstGeom>
           <a:solidFill>
-            <a:srgbClr val="581C87"/>
+            <a:srgbClr val="D97706"/>
           </a:solidFill>
           <a:ln/>
         </p:spPr>
@@ -5516,10 +5516,10 @@
             <a:r>
               <a:rPr lang="en-US" sz="900" b="1" dirty="0">
                 <a:solidFill>
-                  <a:srgbClr val="D8B4FE"/>
-                </a:solidFill>
-              </a:rPr>
-              <a:t>PLANNED</a:t>
+                  <a:srgbClr val="FDE68A"/>
+                </a:solidFill>
+              </a:rPr>
+              <a:t>DELIVERED TODAY</a:t>
             </a:r>
             <a:endParaRPr lang="en-US" sz="900" dirty="0"/>
           </a:p>
@@ -5555,7 +5555,7 @@
                   <a:srgbClr val="F9FAFB"/>
                 </a:solidFill>
               </a:rPr>
-              <a:t>PHASE 3 (NEXT STEPS)</a:t>
+              <a:t>PHASE 3 (CHAOS SUITE)</a:t>
             </a:r>
             <a:endParaRPr lang="en-US" sz="1400" dirty="0"/>
           </a:p>
@@ -5591,10 +5591,10 @@
             <a:r>
               <a:rPr lang="en-US" sz="1200" dirty="0">
                 <a:solidFill>
-                  <a:srgbClr val="9CA3AF"/>
-                </a:solidFill>
-              </a:rPr>
-              <a:t>⏳ Confetti burst particle explosion
+                  <a:srgbClr val="D1FAE5"/>
+                </a:solidFill>
+              </a:rPr>
+              <a:t>✅ Direct Desktop Invasion (Visitor on screen)
 </a:t>
             </a:r>
             <a:pPr indent="0" marL="0">
@@ -5606,10 +5606,10 @@
             <a:r>
               <a:rPr lang="en-US" sz="1200" dirty="0">
                 <a:solidFill>
-                  <a:srgbClr val="9CA3AF"/>
-                </a:solidFill>
-              </a:rPr>
-              <a:t>⏳ Screen shake CSS feedback
+                  <a:srgbClr val="D1FAE5"/>
+                </a:solidFill>
+              </a:rPr>
+              <a:t>✅ Drag, Drop &amp; Fling Icon Physics
 </a:t>
             </a:r>
             <a:pPr indent="0" marL="0">
@@ -5621,10 +5621,10 @@
             <a:r>
               <a:rPr lang="en-US" sz="1200" dirty="0">
                 <a:solidFill>
-                  <a:srgbClr val="9CA3AF"/>
-                </a:solidFill>
-              </a:rPr>
-              <a:t>⏳ Mischievous sound FX &amp; audio cues
+                  <a:srgbClr val="D1FAE5"/>
+                </a:solidFill>
+              </a:rPr>
+              <a:t>✅ Window Smashing &amp; Prank Popups
 </a:t>
             </a:r>
             <a:pPr indent="0" marL="0">
@@ -5636,10 +5636,10 @@
             <a:r>
               <a:rPr lang="en-US" sz="1200" dirty="0">
                 <a:solidFill>
-                  <a:srgbClr val="9CA3AF"/>
-                </a:solidFill>
-              </a:rPr>
-              <a:t>⏳ WebXR AR Mode (Gremlin on desk)
+                  <a:srgbClr val="D1FAE5"/>
+                </a:solidFill>
+              </a:rPr>
+              <a:t>✅ WebRTC Real Desktop Screen Streaming
 </a:t>
             </a:r>
             <a:pPr indent="0" marL="0">
@@ -5651,10 +5651,40 @@
             <a:r>
               <a:rPr lang="en-US" sz="1200" dirty="0">
                 <a:solidFill>
-                  <a:srgbClr val="9CA3AF"/>
-                </a:solidFill>
-              </a:rPr>
-              <a:t>⏳ Twitch / Streamer interactive bot
+                  <a:srgbClr val="D1FAE5"/>
+                </a:solidFill>
+              </a:rPr>
+              <a:t>✅ Earthquake Shake &amp; Confetti Explosions
+</a:t>
+            </a:r>
+            <a:pPr indent="0" marL="0">
+              <a:lnSpc>
+                <a:spcPts val="1600"/>
+              </a:lnSpc>
+              <a:buNone/>
+            </a:pPr>
+            <a:r>
+              <a:rPr lang="en-US" sz="1200" dirty="0">
+                <a:solidFill>
+                  <a:srgbClr val="D1FAE5"/>
+                </a:solidFill>
+              </a:rPr>
+              <a:t>✅ Graffiti Stamps &amp; Sticky Notes
+</a:t>
+            </a:r>
+            <a:pPr indent="0" marL="0">
+              <a:lnSpc>
+                <a:spcPts val="1600"/>
+              </a:lnSpc>
+              <a:buNone/>
+            </a:pPr>
+            <a:r>
+              <a:rPr lang="en-US" sz="1200" dirty="0">
+                <a:solidFill>
+                  <a:srgbClr val="D1FAE5"/>
+                </a:solidFill>
+              </a:rPr>
+              <a:t>✅ Web Audio Procedural 8-bit Sound FX
 </a:t>
             </a:r>
             <a:endParaRPr lang="en-US" sz="1200" dirty="0"/>
@@ -6431,7 +6461,7 @@
                   <a:srgbClr val="F59E0B"/>
                 </a:solidFill>
               </a:rPr>
-              <a:t>2. Host Session: </a:t>
+              <a:t>2. Host Desktop: </a:t>
             </a:r>
             <a:pPr indent="0" marL="0">
               <a:lnSpc>
@@ -6445,7 +6475,7 @@
                   <a:srgbClr val="F9FAFB"/>
                 </a:solidFill>
               </a:rPr>
-              <a:t>Open displayed terminal URL, click 'Host a Session'
+              <a:t>Click '🖥️ Host a Desktop' (optionally click 'Stream Real Desktop')
 </a:t>
             </a:r>
             <a:pPr indent="0" marL="0">
@@ -6460,7 +6490,7 @@
                   <a:srgbClr val="F59E0B"/>
                 </a:solidFill>
               </a:rPr>
-              <a:t>3. Join &amp; Track: </a:t>
+              <a:t>3. Invade &amp; Cause Chaos: </a:t>
             </a:r>
             <a:pPr indent="0" marL="0">
               <a:lnSpc>
@@ -6474,7 +6504,7 @@
                   <a:srgbClr val="F9FAFB"/>
                 </a:solidFill>
               </a:rPr>
-              <a:t>Enter code, click '📷 Enable Camera', and control the 3D Gremlin Head with your face!</a:t>
+              <a:t>Click '🕹️ Invade a Desktop', enter PIN, and drag files, smash windows, spray graffiti, and shake the screen!</a:t>
             </a:r>
             <a:endParaRPr lang="en-US" sz="1300" dirty="0"/>
           </a:p>

</xml_diff>